<commit_message>
Slides: weeks 1, 2, 3, 11, 15, 18 decks; ledger update
Co-Authored-By: Claude Opus 5.5 <noreply@anthropic.com>
Claude-Session: https://claude.ai/code/session_01XkzKv8pUGMF9AsqSCMpnBq
</commit_message>
<xml_diff>
--- a/slides/decks/s01-hla-donor-source.pptx
+++ b/slides/decks/s01-hla-donor-source.pptx
@@ -133,20 +133,20 @@
   <p:extLst>
     <p:ext uri="{521415D9-36F7-43E2-AB2F-B90AF26B5E84}">
       <p14:sectionLst xmlns:p14="http://schemas.microsoft.com/office/powerpoint/2010/main">
-        <p14:section name="Opening" id="{2dc5a3ef-7ceb-b356-1c42-62de6b0034c8}">
+        <p14:section name="Opening" id="{a9fa8cfd-7d7d-b9b1-e520-6bf525005105}">
           <p14:sldIdLst>
             <p14:sldId id="256"/>
             <p14:sldId id="257"/>
           </p14:sldIdLst>
         </p14:section>
-        <p14:section name="HLA biology and typing" id="{73d140e3-0617-0337-78c0-5c2f80862ecd}">
+        <p14:section name="HLA biology and typing" id="{06448675-31a1-172d-c1c2-a4b2a1618aa6}">
           <p14:sldIdLst>
             <p14:sldId id="258"/>
             <p14:sldId id="259"/>
             <p14:sldId id="260"/>
           </p14:sldIdLst>
         </p14:section>
-        <p14:section name="Matching by donor type" id="{b80fc1e5-0fd8-680d-3a4d-1224183554c2}">
+        <p14:section name="Matching by donor type" id="{56887b70-9e89-3a32-41a1-2485b138c4fa}">
           <p14:sldIdLst>
             <p14:sldId id="261"/>
             <p14:sldId id="262"/>
@@ -154,21 +154,21 @@
             <p14:sldId id="264"/>
           </p14:sldIdLst>
         </p14:section>
-        <p14:section name="Choosing the donor" id="{64562ee0-1670-04bb-ed4c-ac5a0bfac147}">
+        <p14:section name="Choosing the donor" id="{f2924cc7-dbe7-def1-1aad-d3e694e70e84}">
           <p14:sldIdLst>
             <p14:sldId id="265"/>
             <p14:sldId id="266"/>
             <p14:sldId id="267"/>
           </p14:sldIdLst>
         </p14:section>
-        <p14:section name="Stem cell source" id="{bb23921c-62dc-fa0c-0965-050ba4dbdc22}">
+        <p14:section name="Stem cell source" id="{db8ea254-5bfb-cbac-2f1d-ad14ebdc1510}">
           <p14:sldIdLst>
             <p14:sldId id="268"/>
             <p14:sldId id="269"/>
             <p14:sldId id="270"/>
           </p14:sldIdLst>
         </p14:section>
-        <p14:section name="Board questions" id="{0cfc751f-3054-0afc-6efd-3338749e6aa6}">
+        <p14:section name="Board questions" id="{4542e9b4-eab8-5846-527e-0665291ba8ed}">
           <p14:sldIdLst>
             <p14:sldId id="271"/>
             <p14:sldId id="272"/>
@@ -178,13 +178,13 @@
             <p14:sldId id="276"/>
           </p14:sldIdLst>
         </p14:section>
-        <p14:section name="References" id="{ff79c2f7-4ce3-9d08-993b-e5ac94178388}">
+        <p14:section name="References" id="{fd36f3ab-80fb-e02f-4455-80894f4a373f}">
           <p14:sldIdLst>
             <p14:sldId id="277"/>
             <p14:sldId id="278"/>
           </p14:sldIdLst>
         </p14:section>
-        <p14:section name="Backup" id="{75f8a440-5b2b-bd8f-bf25-eaca79751b2f}">
+        <p14:section name="Backup" id="{3d1cd2ec-8116-fbb4-d60f-9f8cafb06314}">
           <p14:sldIdLst>
             <p14:sldId id="279"/>
             <p14:sldId id="280"/>
@@ -19078,7 +19078,7 @@
                             <a:schemeClr val="tx1"/>
                           </a:solidFill>
                         </a:rPr>
-                        <a:t>Polymorphic α-chain + monomorphic β2m</a:t>
+                        <a:t>Polymorphic α-chain + β2m</a:t>
                       </a:r>
                       <a:endParaRPr lang="en-US" sz="1800" dirty="0"/>
                     </a:p>
@@ -21512,7 +21512,7 @@
                             <a:schemeClr val="tx1"/>
                           </a:solidFill>
                         </a:rPr>
-                        <a:t>Chance of finding one</a:t>
+                        <a:t>Availability</a:t>
                       </a:r>
                       <a:endParaRPr lang="en-US" sz="1800" dirty="0"/>
                     </a:p>

</xml_diff>

<commit_message>
Slides: all 18 sessions final, README and verification ledger
Co-Authored-By: Claude Opus 5.5 <noreply@anthropic.com>
Claude-Session: https://claude.ai/code/session_01XkzKv8pUGMF9AsqSCMpnBq
</commit_message>
<xml_diff>
--- a/slides/decks/s01-hla-donor-source.pptx
+++ b/slides/decks/s01-hla-donor-source.pptx
@@ -133,20 +133,20 @@
   <p:extLst>
     <p:ext uri="{521415D9-36F7-43E2-AB2F-B90AF26B5E84}">
       <p14:sectionLst xmlns:p14="http://schemas.microsoft.com/office/powerpoint/2010/main">
-        <p14:section name="Opening" id="{a9fa8cfd-7d7d-b9b1-e520-6bf525005105}">
+        <p14:section name="Opening" id="{9b268f15-fd46-b912-6715-f28c3b6e6dd9}">
           <p14:sldIdLst>
             <p14:sldId id="256"/>
             <p14:sldId id="257"/>
           </p14:sldIdLst>
         </p14:section>
-        <p14:section name="HLA biology and typing" id="{06448675-31a1-172d-c1c2-a4b2a1618aa6}">
+        <p14:section name="HLA biology and typing" id="{c9a4df5b-aa6a-9fb8-0584-60e581ca975b}">
           <p14:sldIdLst>
             <p14:sldId id="258"/>
             <p14:sldId id="259"/>
             <p14:sldId id="260"/>
           </p14:sldIdLst>
         </p14:section>
-        <p14:section name="Matching by donor type" id="{56887b70-9e89-3a32-41a1-2485b138c4fa}">
+        <p14:section name="Matching by donor type" id="{b3dd42da-d962-61bf-fc22-4cb273a81f69}">
           <p14:sldIdLst>
             <p14:sldId id="261"/>
             <p14:sldId id="262"/>
@@ -154,21 +154,21 @@
             <p14:sldId id="264"/>
           </p14:sldIdLst>
         </p14:section>
-        <p14:section name="Choosing the donor" id="{f2924cc7-dbe7-def1-1aad-d3e694e70e84}">
+        <p14:section name="Choosing the donor" id="{776ecf2d-31bc-e0b8-1064-7489f776a56a}">
           <p14:sldIdLst>
             <p14:sldId id="265"/>
             <p14:sldId id="266"/>
             <p14:sldId id="267"/>
           </p14:sldIdLst>
         </p14:section>
-        <p14:section name="Stem cell source" id="{db8ea254-5bfb-cbac-2f1d-ad14ebdc1510}">
+        <p14:section name="Stem cell source" id="{f568db7f-5951-e2ee-9778-c8bdc5f383f1}">
           <p14:sldIdLst>
             <p14:sldId id="268"/>
             <p14:sldId id="269"/>
             <p14:sldId id="270"/>
           </p14:sldIdLst>
         </p14:section>
-        <p14:section name="Board questions" id="{4542e9b4-eab8-5846-527e-0665291ba8ed}">
+        <p14:section name="Board questions" id="{5f102977-27b4-a5da-6045-471e5d4a6c9e}">
           <p14:sldIdLst>
             <p14:sldId id="271"/>
             <p14:sldId id="272"/>
@@ -178,13 +178,13 @@
             <p14:sldId id="276"/>
           </p14:sldIdLst>
         </p14:section>
-        <p14:section name="References" id="{fd36f3ab-80fb-e02f-4455-80894f4a373f}">
+        <p14:section name="References" id="{446c3981-ab87-0385-0090-da3ec58e6f53}">
           <p14:sldIdLst>
             <p14:sldId id="277"/>
             <p14:sldId id="278"/>
           </p14:sldIdLst>
         </p14:section>
-        <p14:section name="Backup" id="{3d1cd2ec-8116-fbb4-d60f-9f8cafb06314}">
+        <p14:section name="Backup" id="{3b0db69b-dc46-b019-3ffe-cdd21ce9f391}">
           <p14:sldIdLst>
             <p14:sldId id="279"/>
             <p14:sldId id="280"/>

</xml_diff>

<commit_message>
Slides: move to 29-session curriculum; renumber the 9 unchanged decks
Co-Authored-By: Claude Opus 5.5 <noreply@anthropic.com>
Claude-Session: https://claude.ai/code/session_01XkzKv8pUGMF9AsqSCMpnBq
</commit_message>
<xml_diff>
--- a/slides/decks/s01-hla-donor-source.pptx
+++ b/slides/decks/s01-hla-donor-source.pptx
@@ -133,20 +133,20 @@
   <p:extLst>
     <p:ext uri="{521415D9-36F7-43E2-AB2F-B90AF26B5E84}">
       <p14:sectionLst xmlns:p14="http://schemas.microsoft.com/office/powerpoint/2010/main">
-        <p14:section name="Opening" id="{9b268f15-fd46-b912-6715-f28c3b6e6dd9}">
+        <p14:section name="Opening" id="{4d810884-b4e6-1c3a-712c-3b29acaad5e6}">
           <p14:sldIdLst>
             <p14:sldId id="256"/>
             <p14:sldId id="257"/>
           </p14:sldIdLst>
         </p14:section>
-        <p14:section name="HLA biology and typing" id="{c9a4df5b-aa6a-9fb8-0584-60e581ca975b}">
+        <p14:section name="HLA biology and typing" id="{1dfec5b8-00e9-9c2c-5d61-8a1a5359789f}">
           <p14:sldIdLst>
             <p14:sldId id="258"/>
             <p14:sldId id="259"/>
             <p14:sldId id="260"/>
           </p14:sldIdLst>
         </p14:section>
-        <p14:section name="Matching by donor type" id="{b3dd42da-d962-61bf-fc22-4cb273a81f69}">
+        <p14:section name="Matching by donor type" id="{414a6d1b-4c55-c182-35ea-8e605b6bf0fb}">
           <p14:sldIdLst>
             <p14:sldId id="261"/>
             <p14:sldId id="262"/>
@@ -154,21 +154,21 @@
             <p14:sldId id="264"/>
           </p14:sldIdLst>
         </p14:section>
-        <p14:section name="Choosing the donor" id="{776ecf2d-31bc-e0b8-1064-7489f776a56a}">
+        <p14:section name="Choosing the donor" id="{020d6743-3b16-afdf-ba26-08d6e41d4245}">
           <p14:sldIdLst>
             <p14:sldId id="265"/>
             <p14:sldId id="266"/>
             <p14:sldId id="267"/>
           </p14:sldIdLst>
         </p14:section>
-        <p14:section name="Stem cell source" id="{f568db7f-5951-e2ee-9778-c8bdc5f383f1}">
+        <p14:section name="Stem cell source" id="{4dcc0374-90ef-8c0c-97a4-83680560b9e1}">
           <p14:sldIdLst>
             <p14:sldId id="268"/>
             <p14:sldId id="269"/>
             <p14:sldId id="270"/>
           </p14:sldIdLst>
         </p14:section>
-        <p14:section name="Board questions" id="{5f102977-27b4-a5da-6045-471e5d4a6c9e}">
+        <p14:section name="Board questions" id="{752d8f50-0f17-15f8-7fe8-278f9248d053}">
           <p14:sldIdLst>
             <p14:sldId id="271"/>
             <p14:sldId id="272"/>
@@ -178,13 +178,13 @@
             <p14:sldId id="276"/>
           </p14:sldIdLst>
         </p14:section>
-        <p14:section name="References" id="{446c3981-ab87-0385-0090-da3ec58e6f53}">
+        <p14:section name="References" id="{1b085e67-85c4-cc10-da7d-f1962a808885}">
           <p14:sldIdLst>
             <p14:sldId id="277"/>
             <p14:sldId id="278"/>
           </p14:sldIdLst>
         </p14:section>
-        <p14:section name="Backup" id="{3b0db69b-dc46-b019-3ffe-cdd21ce9f391}">
+        <p14:section name="Backup" id="{52c3558f-fb56-bc77-2176-3067b00012dc}">
           <p14:sldIdLst>
             <p14:sldId id="279"/>
             <p14:sldId id="280"/>
@@ -612,7 +612,7 @@
             </a:pPr>
             <a:r>
               <a:rPr lang="en-US" dirty="0"/>
-              <a:t>各位早安，第一週從移植最根本的問題開始，donor 怎麼選、HLA 要配到什麼程度、stem cell 從哪裡來。內容取自 EBMT Handbook 第 9、12、14 章。這三章的數字很多，考試常直接拿來出題，今天會把重點放在機率、cutoff 和 trial 結果，最後用三題 board-style 題目收尾。每一題都會對應前面某一張投影片。</a:t>
+              <a:t>各位早安，第 1 堂從移植最根本的問題開始，donor 怎麼選、HLA 要配到什麼程度、stem cell 從哪裡來。內容取自 EBMT Handbook 第 9、12、14 章。這三章的數字很多，考試常直接拿來出題，今天會把重點放在機率、cutoff 和 trial 結果，最後用三題 board-style 題目收尾。每一題都會對應前面某一張投影片。</a:t>
             </a:r>
           </a:p>
         </p:txBody>
@@ -5057,7 +5057,7 @@
                   <a:schemeClr val="tx1"/>
                 </a:solidFill>
               </a:rPr>
-              <a:t>Week 1 · Ch. 9, 12, 14</a:t>
+              <a:t>Session 01 · Ch. 9, 12, 14</a:t>
             </a:r>
             <a:endParaRPr lang="en-US" sz="2000" dirty="0"/>
           </a:p>

</xml_diff>

<commit_message>
Slides: all 29 sessions final; README and verification ledger
Co-Authored-By: Claude Opus 5.5 <noreply@anthropic.com>
Claude-Session: https://claude.ai/code/session_01XkzKv8pUGMF9AsqSCMpnBq
</commit_message>
<xml_diff>
--- a/slides/decks/s01-hla-donor-source.pptx
+++ b/slides/decks/s01-hla-donor-source.pptx
@@ -133,20 +133,20 @@
   <p:extLst>
     <p:ext uri="{521415D9-36F7-43E2-AB2F-B90AF26B5E84}">
       <p14:sectionLst xmlns:p14="http://schemas.microsoft.com/office/powerpoint/2010/main">
-        <p14:section name="Opening" id="{4d810884-b4e6-1c3a-712c-3b29acaad5e6}">
+        <p14:section name="Opening" id="{af21f075-63a9-3df0-6816-6a537d36fd42}">
           <p14:sldIdLst>
             <p14:sldId id="256"/>
             <p14:sldId id="257"/>
           </p14:sldIdLst>
         </p14:section>
-        <p14:section name="HLA biology and typing" id="{1dfec5b8-00e9-9c2c-5d61-8a1a5359789f}">
+        <p14:section name="HLA biology and typing" id="{ccbb7099-bcaa-f2b3-9d51-891675268170}">
           <p14:sldIdLst>
             <p14:sldId id="258"/>
             <p14:sldId id="259"/>
             <p14:sldId id="260"/>
           </p14:sldIdLst>
         </p14:section>
-        <p14:section name="Matching by donor type" id="{414a6d1b-4c55-c182-35ea-8e605b6bf0fb}">
+        <p14:section name="Matching by donor type" id="{07cf369e-3362-72a1-289a-cd88f76c9a11}">
           <p14:sldIdLst>
             <p14:sldId id="261"/>
             <p14:sldId id="262"/>
@@ -154,21 +154,21 @@
             <p14:sldId id="264"/>
           </p14:sldIdLst>
         </p14:section>
-        <p14:section name="Choosing the donor" id="{020d6743-3b16-afdf-ba26-08d6e41d4245}">
+        <p14:section name="Choosing the donor" id="{d959272d-813e-41dc-fa68-85149a0ddc12}">
           <p14:sldIdLst>
             <p14:sldId id="265"/>
             <p14:sldId id="266"/>
             <p14:sldId id="267"/>
           </p14:sldIdLst>
         </p14:section>
-        <p14:section name="Stem cell source" id="{4dcc0374-90ef-8c0c-97a4-83680560b9e1}">
+        <p14:section name="Stem cell source" id="{8b041948-1c05-2f9c-99dc-c41b87f4d067}">
           <p14:sldIdLst>
             <p14:sldId id="268"/>
             <p14:sldId id="269"/>
             <p14:sldId id="270"/>
           </p14:sldIdLst>
         </p14:section>
-        <p14:section name="Board questions" id="{752d8f50-0f17-15f8-7fe8-278f9248d053}">
+        <p14:section name="Board questions" id="{5c3c26bf-8994-cbcf-e041-19239afb46e1}">
           <p14:sldIdLst>
             <p14:sldId id="271"/>
             <p14:sldId id="272"/>
@@ -178,13 +178,13 @@
             <p14:sldId id="276"/>
           </p14:sldIdLst>
         </p14:section>
-        <p14:section name="References" id="{1b085e67-85c4-cc10-da7d-f1962a808885}">
+        <p14:section name="References" id="{c63e24fe-6739-b5bc-9a22-3b408bf05548}">
           <p14:sldIdLst>
             <p14:sldId id="277"/>
             <p14:sldId id="278"/>
           </p14:sldIdLst>
         </p14:section>
-        <p14:section name="Backup" id="{52c3558f-fb56-bc77-2176-3067b00012dc}">
+        <p14:section name="Backup" id="{75d8ffda-1dbe-4e0e-6ade-19cfbbb7802b}">
           <p14:sldIdLst>
             <p14:sldId id="279"/>
             <p14:sldId id="280"/>

</xml_diff>